<commit_message>
Roadmap script: start with what phase 1 is and its goal; no reference to slides not yet shown
Co-Authored-By: Claude Sonnet 5.5 <noreply@anthropic.com>
</commit_message>
<xml_diff>
--- a/deck/journey/Roadmap.pptx
+++ b/deck/journey/Roadmap.pptx
@@ -504,15 +504,18 @@
               <a:rPr lang="en-US" dirty="0"/>
               <a:t>This is the roadmap. Three phases, about a year. The months are illustrative. What I want you to take away is the order, and why.
 My rule is simple. Each phase earns the next one. I don't build the next layer on something I haven't proven.
-Phase 1 has two milestones.
-Milestone 1 is building the library. That is Part 1, the one we just saw. The business value is one central place with every policy we cover, and exactly what each one wants checked. Today that knowledge lives in documents and in people's heads. In the library, every rule traces to the policy's own words. Every change is versioned and audited. And once a policy is approved, the next service reuses it. This milestone alone doesn't move a metric. It is the foundation. So I measure it by how fast we can onboard a service, and whether every rule traces back to an exact quote.
-Milestone 2 is deciding every packet. That is Part 2, and this is where the north star moves. Right-first-time rate. Out of every 100 requests, how many get the right answer the first time, with no back and forth. It helps everyone. The nurse stops hunting through the packet. The provider stops re-sending. The member gets a decision sooner. And the plan has fewer appeals and meets the CMS clock.
+Let me start with Phase 1, because it is the heart of this.
+Phase 1 has one goal. Get each request decided right the first time, with a person still making the decision. The measure is the right-first-time rate. That is my north star. Out of every 100 requests, how many get the right answer the first time, with no back and forth.
+To get there, Phase 1 has two milestones. They ladder up to that goal, and the first makes the second possible.
+Milestone 1 is to build the library. Think of it as the rulebook. It is one central place with every policy we cover, written as a checklist of exactly what each one wants to see in a request. Today that knowledge lives in documents and in people's heads. In the library, every item traces back to the policy's own words. Every change is versioned and audited. And once a policy is in, the next service reuses it. This milestone doesn't move the north star by itself. It is the foundation. So I measure it by how fast we can add a service, and whether every item traces to an exact quote.
+Milestone 2 is to decide every packet. When a request comes in, the AI checks it against that checklist and gives the nurse a recommendation, with the evidence. The nurse confirms. This is where the north star moves. It helps everyone. The nurse stops hunting through the packet. The provider stops re-sending. The member gets a decision sooner. And the plan has fewer appeals and meets the CMS clock.
 Why start here? Three reasons. First, this is where the delay lives. A pend doesn't stop the CMS clock, so every avoidable pend is a lost loop. Second, it is the safest place to start, because a person decides every case. The AI recommends, the nurse confirms, and only the director can deny. Third, it builds the record: every decision, with its evidence. Everything after this depends on that record.
 And why the library before the packets? Because the AI only ever uses what a person approved. If the library is wrong, every packet is wrong. So I make the foundation solid first. Then I run it in shadow, beside the nurses, before any nurse sees a recommendation. The gate to leave Phase 1 is a tested library, and evals on real labeled cases with zero wrong approvals.
-Phase 2 is scale. I add services one at a time, ranked by Humana's own request history. Why now and not earlier? The onboarding flow is already built, and each new service reuses policies. But I only widen after Phase 1 is proven. Each new service has its own gate, and the ML team owns the test packets. The value goes to the plan: more of the volume covered.
+Phase 2 is scale. I add services one at a time, ranked by Humana's own request history. Why now and not earlier? How I add a service is already designed, and each new service reuses policies. But I only widen after Phase 1 is proven. Each new service has its own gate, and the ML team owns the test packets. The value goes to the plan: more of the volume covered.
 Phase 3 is member status. The member sees where a request stands. Why last? A status is only as good as the record behind it. If I show a member a status I can't stand behind, I make things worse. So it reads the trusted record from the first two phases, and it needs a compliance review before a member sees anything.
 I'll be honest about the date. From January 2027, plans must offer a Patient Access API with prior authorization information. A year-long plan lands after that. So I'm not saying this phase meets the requirement. I'm saying it builds on the record, next to whatever the plan builds for the mandate.
-So the roadmap is a trust ladder. Prove it is right. Then widen it. Then show it to the member. A person decides in every phase, and the AI never denies. I'll talk about the money after the demo.</a:t>
+So the roadmap is a trust ladder. Prove it is right. Then widen it. Then show it to the member. A person decides in every phase, and the AI never denies.
+Now let me show you what Phase 1 looks like, step by step.</a:t>
             </a:r>
             <a:endParaRPr lang="en-US" dirty="0"/>
           </a:p>
@@ -1176,7 +1179,7 @@
                 <a:ea typeface="Calibri" pitchFamily="34" charset="-122"/>
                 <a:cs typeface="Calibri" pitchFamily="34" charset="-120"/>
               </a:rPr>
-              <a:t>North star: right-first-time rate</a:t>
+              <a:t>North star: right-first-time rate. Two milestones ladder up to it.</a:t>
             </a:r>
             <a:endParaRPr lang="en-US" sz="1150" dirty="0"/>
           </a:p>

</xml_diff>